<commit_message>
Les deux PPTX regeneres, marquage retire de la version projetee
Verifie sur le rendu : la version projetee ne porte le marquage de conformite sur
aucune des 33 diapositives, celle de repetition le porte sur 29, les deux
gardent le numero de diapositive sur 31 et les notes sur 33. Les deux couvertures
n'ont pas de pied de page, d'ou l'ecart de deux.

Le numero reste des deux cotes : c'est lui qui relie le support projete a la
feuille A4 remise au jury.

Co-Authored-By: Claude Opus 5 <noreply@anthropic.com>
</commit_message>
<xml_diff>
--- a/docs/support_soutenance.pptx
+++ b/docs/support_soutenance.pptx
@@ -7929,45 +7929,6 @@
         </p:nvSpPr>
         <p:spPr>
           <a:xfrm>
-            <a:off x="786384" y="6254496"/>
-            <a:ext cx="8229600" cy="274320"/>
-          </a:xfrm>
-          <a:prstGeom prst="rect">
-            <a:avLst/>
-          </a:prstGeom>
-          <a:noFill/>
-        </p:spPr>
-        <p:txBody>
-          <a:bodyPr wrap="square" lIns="0" rIns="0" tIns="0" bIns="0">
-            <a:spAutoFit/>
-          </a:bodyPr>
-          <a:lstStyle/>
-          <a:p>
-            <a:pPr algn="l">
-              <a:spcBef>
-                <a:spcPts val="0"/>
-              </a:spcBef>
-            </a:pPr>
-            <a:r>
-              <a:rPr sz="900" b="0">
-                <a:solidFill>
-                  <a:srgbClr val="52514E"/>
-                </a:solidFill>
-                <a:latin typeface="Segoe UI"/>
-              </a:rPr>
-              <a:t>D10   ·   07:40   ·   C4.2.1   ·   criteres 11</a:t>
-            </a:r>
-          </a:p>
-        </p:txBody>
-      </p:sp>
-      <p:sp>
-        <p:nvSpPr>
-          <p:cNvPr id="15" name="TextBox 14"/>
-          <p:cNvSpPr txBox="1"/>
-          <p:nvPr/>
-        </p:nvSpPr>
-        <p:spPr>
-          <a:xfrm>
             <a:off x="10070287" y="6254496"/>
             <a:ext cx="1463040" cy="274320"/>
           </a:xfrm>
@@ -8480,45 +8441,6 @@
         </p:nvSpPr>
         <p:spPr>
           <a:xfrm>
-            <a:off x="786384" y="6254496"/>
-            <a:ext cx="8229600" cy="274320"/>
-          </a:xfrm>
-          <a:prstGeom prst="rect">
-            <a:avLst/>
-          </a:prstGeom>
-          <a:noFill/>
-        </p:spPr>
-        <p:txBody>
-          <a:bodyPr wrap="square" lIns="0" rIns="0" tIns="0" bIns="0">
-            <a:spAutoFit/>
-          </a:bodyPr>
-          <a:lstStyle/>
-          <a:p>
-            <a:pPr algn="l">
-              <a:spcBef>
-                <a:spcPts val="0"/>
-              </a:spcBef>
-            </a:pPr>
-            <a:r>
-              <a:rPr sz="900" b="0">
-                <a:solidFill>
-                  <a:srgbClr val="52514E"/>
-                </a:solidFill>
-                <a:latin typeface="Segoe UI"/>
-              </a:rPr>
-              <a:t>D10r   ·   07:40   ·   C4.2.1   ·   criteres 11</a:t>
-            </a:r>
-          </a:p>
-        </p:txBody>
-      </p:sp>
-      <p:sp>
-        <p:nvSpPr>
-          <p:cNvPr id="10" name="TextBox 9"/>
-          <p:cNvSpPr txBox="1"/>
-          <p:nvPr/>
-        </p:nvSpPr>
-        <p:spPr>
-          <a:xfrm>
             <a:off x="10070287" y="6254496"/>
             <a:ext cx="1463040" cy="274320"/>
           </a:xfrm>
@@ -9601,45 +9523,6 @@
         </p:nvSpPr>
         <p:spPr>
           <a:xfrm>
-            <a:off x="786384" y="6254496"/>
-            <a:ext cx="8229600" cy="274320"/>
-          </a:xfrm>
-          <a:prstGeom prst="rect">
-            <a:avLst/>
-          </a:prstGeom>
-          <a:noFill/>
-        </p:spPr>
-        <p:txBody>
-          <a:bodyPr wrap="square" lIns="0" rIns="0" tIns="0" bIns="0">
-            <a:spAutoFit/>
-          </a:bodyPr>
-          <a:lstStyle/>
-          <a:p>
-            <a:pPr algn="l">
-              <a:spcBef>
-                <a:spcPts val="0"/>
-              </a:spcBef>
-            </a:pPr>
-            <a:r>
-              <a:rPr sz="900" b="0">
-                <a:solidFill>
-                  <a:srgbClr val="52514E"/>
-                </a:solidFill>
-                <a:latin typeface="Segoe UI"/>
-              </a:rPr>
-              <a:t>D11   ·   08:30   ·   C4.2.1   ·   criteres 10, 12</a:t>
-            </a:r>
-          </a:p>
-        </p:txBody>
-      </p:sp>
-      <p:sp>
-        <p:nvSpPr>
-          <p:cNvPr id="27" name="TextBox 26"/>
-          <p:cNvSpPr txBox="1"/>
-          <p:nvPr/>
-        </p:nvSpPr>
-        <p:spPr>
-          <a:xfrm>
             <a:off x="10070287" y="6254496"/>
             <a:ext cx="1463040" cy="274320"/>
           </a:xfrm>
@@ -10165,45 +10048,6 @@
         </p:nvSpPr>
         <p:spPr>
           <a:xfrm>
-            <a:off x="786384" y="6254496"/>
-            <a:ext cx="8229600" cy="274320"/>
-          </a:xfrm>
-          <a:prstGeom prst="rect">
-            <a:avLst/>
-          </a:prstGeom>
-          <a:noFill/>
-        </p:spPr>
-        <p:txBody>
-          <a:bodyPr wrap="square" lIns="0" rIns="0" tIns="0" bIns="0">
-            <a:spAutoFit/>
-          </a:bodyPr>
-          <a:lstStyle/>
-          <a:p>
-            <a:pPr algn="l">
-              <a:spcBef>
-                <a:spcPts val="0"/>
-              </a:spcBef>
-            </a:pPr>
-            <a:r>
-              <a:rPr sz="900" b="0">
-                <a:solidFill>
-                  <a:srgbClr val="52514E"/>
-                </a:solidFill>
-                <a:latin typeface="Segoe UI"/>
-              </a:rPr>
-              <a:t>D12   ·   09:30   ·   C4.2.2   ·   criteres 13, 14, 15</a:t>
-            </a:r>
-          </a:p>
-        </p:txBody>
-      </p:sp>
-      <p:sp>
-        <p:nvSpPr>
-          <p:cNvPr id="14" name="TextBox 13"/>
-          <p:cNvSpPr txBox="1"/>
-          <p:nvPr/>
-        </p:nvSpPr>
-        <p:spPr>
-          <a:xfrm>
             <a:off x="10070287" y="6254496"/>
             <a:ext cx="1463040" cy="274320"/>
           </a:xfrm>
@@ -10862,45 +10706,6 @@
         </p:nvSpPr>
         <p:spPr>
           <a:xfrm>
-            <a:off x="786384" y="6254496"/>
-            <a:ext cx="8229600" cy="274320"/>
-          </a:xfrm>
-          <a:prstGeom prst="rect">
-            <a:avLst/>
-          </a:prstGeom>
-          <a:noFill/>
-        </p:spPr>
-        <p:txBody>
-          <a:bodyPr wrap="square" lIns="0" rIns="0" tIns="0" bIns="0">
-            <a:spAutoFit/>
-          </a:bodyPr>
-          <a:lstStyle/>
-          <a:p>
-            <a:pPr algn="l">
-              <a:spcBef>
-                <a:spcPts val="0"/>
-              </a:spcBef>
-            </a:pPr>
-            <a:r>
-              <a:rPr sz="900" b="0">
-                <a:solidFill>
-                  <a:srgbClr val="52514E"/>
-                </a:solidFill>
-                <a:latin typeface="Segoe UI"/>
-              </a:rPr>
-              <a:t>D13   ·   10:00   ·   C4.2.2   ·   criteres 13</a:t>
-            </a:r>
-          </a:p>
-        </p:txBody>
-      </p:sp>
-      <p:sp>
-        <p:nvSpPr>
-          <p:cNvPr id="17" name="TextBox 16"/>
-          <p:cNvSpPr txBox="1"/>
-          <p:nvPr/>
-        </p:nvSpPr>
-        <p:spPr>
-          <a:xfrm>
             <a:off x="10070287" y="6254496"/>
             <a:ext cx="1463040" cy="274320"/>
           </a:xfrm>
@@ -11606,45 +11411,6 @@
         </p:nvSpPr>
         <p:spPr>
           <a:xfrm>
-            <a:off x="786384" y="6254496"/>
-            <a:ext cx="8229600" cy="274320"/>
-          </a:xfrm>
-          <a:prstGeom prst="rect">
-            <a:avLst/>
-          </a:prstGeom>
-          <a:noFill/>
-        </p:spPr>
-        <p:txBody>
-          <a:bodyPr wrap="square" lIns="0" rIns="0" tIns="0" bIns="0">
-            <a:spAutoFit/>
-          </a:bodyPr>
-          <a:lstStyle/>
-          <a:p>
-            <a:pPr algn="l">
-              <a:spcBef>
-                <a:spcPts val="0"/>
-              </a:spcBef>
-            </a:pPr>
-            <a:r>
-              <a:rPr sz="900" b="0">
-                <a:solidFill>
-                  <a:srgbClr val="52514E"/>
-                </a:solidFill>
-                <a:latin typeface="Segoe UI"/>
-              </a:rPr>
-              <a:t>D14   ·   11:20   ·   C4.2.2   ·   criteres 14</a:t>
-            </a:r>
-          </a:p>
-        </p:txBody>
-      </p:sp>
-      <p:sp>
-        <p:nvSpPr>
-          <p:cNvPr id="17" name="TextBox 16"/>
-          <p:cNvSpPr txBox="1"/>
-          <p:nvPr/>
-        </p:nvSpPr>
-        <p:spPr>
-          <a:xfrm>
             <a:off x="10070287" y="6254496"/>
             <a:ext cx="1463040" cy="274320"/>
           </a:xfrm>
@@ -12221,45 +11987,6 @@
         </p:nvSpPr>
         <p:spPr>
           <a:xfrm>
-            <a:off x="786384" y="6254496"/>
-            <a:ext cx="8229600" cy="274320"/>
-          </a:xfrm>
-          <a:prstGeom prst="rect">
-            <a:avLst/>
-          </a:prstGeom>
-          <a:noFill/>
-        </p:spPr>
-        <p:txBody>
-          <a:bodyPr wrap="square" lIns="0" rIns="0" tIns="0" bIns="0">
-            <a:spAutoFit/>
-          </a:bodyPr>
-          <a:lstStyle/>
-          <a:p>
-            <a:pPr algn="l">
-              <a:spcBef>
-                <a:spcPts val="0"/>
-              </a:spcBef>
-            </a:pPr>
-            <a:r>
-              <a:rPr sz="900" b="0">
-                <a:solidFill>
-                  <a:srgbClr val="52514E"/>
-                </a:solidFill>
-                <a:latin typeface="Segoe UI"/>
-              </a:rPr>
-              <a:t>D14r   ·   11:20   ·   C4.2.2   ·   criteres 14</a:t>
-            </a:r>
-          </a:p>
-        </p:txBody>
-      </p:sp>
-      <p:sp>
-        <p:nvSpPr>
-          <p:cNvPr id="10" name="TextBox 9"/>
-          <p:cNvSpPr txBox="1"/>
-          <p:nvPr/>
-        </p:nvSpPr>
-        <p:spPr>
-          <a:xfrm>
             <a:off x="10070287" y="6254496"/>
             <a:ext cx="1463040" cy="274320"/>
           </a:xfrm>
@@ -12918,45 +12645,6 @@
         </p:nvSpPr>
         <p:spPr>
           <a:xfrm>
-            <a:off x="786384" y="6254496"/>
-            <a:ext cx="8229600" cy="274320"/>
-          </a:xfrm>
-          <a:prstGeom prst="rect">
-            <a:avLst/>
-          </a:prstGeom>
-          <a:noFill/>
-        </p:spPr>
-        <p:txBody>
-          <a:bodyPr wrap="square" lIns="0" rIns="0" tIns="0" bIns="0">
-            <a:spAutoFit/>
-          </a:bodyPr>
-          <a:lstStyle/>
-          <a:p>
-            <a:pPr algn="l">
-              <a:spcBef>
-                <a:spcPts val="0"/>
-              </a:spcBef>
-            </a:pPr>
-            <a:r>
-              <a:rPr sz="900" b="0">
-                <a:solidFill>
-                  <a:srgbClr val="52514E"/>
-                </a:solidFill>
-                <a:latin typeface="Segoe UI"/>
-              </a:rPr>
-              <a:t>D15   ·   12:40   ·   C4.2.2   ·   criteres 15</a:t>
-            </a:r>
-          </a:p>
-        </p:txBody>
-      </p:sp>
-      <p:sp>
-        <p:nvSpPr>
-          <p:cNvPr id="17" name="TextBox 16"/>
-          <p:cNvSpPr txBox="1"/>
-          <p:nvPr/>
-        </p:nvSpPr>
-        <p:spPr>
-          <a:xfrm>
             <a:off x="10070287" y="6254496"/>
             <a:ext cx="1463040" cy="274320"/>
           </a:xfrm>
@@ -13533,45 +13221,6 @@
         </p:nvSpPr>
         <p:spPr>
           <a:xfrm>
-            <a:off x="786384" y="6254496"/>
-            <a:ext cx="8229600" cy="274320"/>
-          </a:xfrm>
-          <a:prstGeom prst="rect">
-            <a:avLst/>
-          </a:prstGeom>
-          <a:noFill/>
-        </p:spPr>
-        <p:txBody>
-          <a:bodyPr wrap="square" lIns="0" rIns="0" tIns="0" bIns="0">
-            <a:spAutoFit/>
-          </a:bodyPr>
-          <a:lstStyle/>
-          <a:p>
-            <a:pPr algn="l">
-              <a:spcBef>
-                <a:spcPts val="0"/>
-              </a:spcBef>
-            </a:pPr>
-            <a:r>
-              <a:rPr sz="900" b="0">
-                <a:solidFill>
-                  <a:srgbClr val="52514E"/>
-                </a:solidFill>
-                <a:latin typeface="Segoe UI"/>
-              </a:rPr>
-              <a:t>D16   ·   13:40   ·   C4.2.2   ·   criteres 15</a:t>
-            </a:r>
-          </a:p>
-        </p:txBody>
-      </p:sp>
-      <p:sp>
-        <p:nvSpPr>
-          <p:cNvPr id="10" name="TextBox 9"/>
-          <p:cNvSpPr txBox="1"/>
-          <p:nvPr/>
-        </p:nvSpPr>
-        <p:spPr>
-          <a:xfrm>
             <a:off x="10070287" y="6254496"/>
             <a:ext cx="1463040" cy="274320"/>
           </a:xfrm>
@@ -13902,45 +13551,6 @@
         </p:nvSpPr>
         <p:spPr>
           <a:xfrm>
-            <a:off x="786384" y="6254496"/>
-            <a:ext cx="8229600" cy="274320"/>
-          </a:xfrm>
-          <a:prstGeom prst="rect">
-            <a:avLst/>
-          </a:prstGeom>
-          <a:noFill/>
-        </p:spPr>
-        <p:txBody>
-          <a:bodyPr wrap="square" lIns="0" rIns="0" tIns="0" bIns="0">
-            <a:spAutoFit/>
-          </a:bodyPr>
-          <a:lstStyle/>
-          <a:p>
-            <a:pPr algn="l">
-              <a:spcBef>
-                <a:spcPts val="0"/>
-              </a:spcBef>
-            </a:pPr>
-            <a:r>
-              <a:rPr sz="900" b="0">
-                <a:solidFill>
-                  <a:srgbClr val="52514E"/>
-                </a:solidFill>
-                <a:latin typeface="Segoe UI"/>
-              </a:rPr>
-              <a:t>D17   ·   15:00   ·   C4.2.3   ·   criteres 16</a:t>
-            </a:r>
-          </a:p>
-        </p:txBody>
-      </p:sp>
-      <p:sp>
-        <p:nvSpPr>
-          <p:cNvPr id="10" name="TextBox 9"/>
-          <p:cNvSpPr txBox="1"/>
-          <p:nvPr/>
-        </p:nvSpPr>
-        <p:spPr>
-          <a:xfrm>
             <a:off x="10070287" y="6254496"/>
             <a:ext cx="1463040" cy="274320"/>
           </a:xfrm>
@@ -15068,45 +14678,6 @@
         </p:nvSpPr>
         <p:spPr>
           <a:xfrm>
-            <a:off x="786384" y="6254496"/>
-            <a:ext cx="8229600" cy="274320"/>
-          </a:xfrm>
-          <a:prstGeom prst="rect">
-            <a:avLst/>
-          </a:prstGeom>
-          <a:noFill/>
-        </p:spPr>
-        <p:txBody>
-          <a:bodyPr wrap="square" lIns="0" rIns="0" tIns="0" bIns="0">
-            <a:spAutoFit/>
-          </a:bodyPr>
-          <a:lstStyle/>
-          <a:p>
-            <a:pPr algn="l">
-              <a:spcBef>
-                <a:spcPts val="0"/>
-              </a:spcBef>
-            </a:pPr>
-            <a:r>
-              <a:rPr sz="900" b="0">
-                <a:solidFill>
-                  <a:srgbClr val="52514E"/>
-                </a:solidFill>
-                <a:latin typeface="Segoe UI"/>
-              </a:rPr>
-              <a:t>D02   ·   00:20</a:t>
-            </a:r>
-          </a:p>
-        </p:txBody>
-      </p:sp>
-      <p:sp>
-        <p:nvSpPr>
-          <p:cNvPr id="28" name="TextBox 27"/>
-          <p:cNvSpPr txBox="1"/>
-          <p:nvPr/>
-        </p:nvSpPr>
-        <p:spPr>
-          <a:xfrm>
             <a:off x="10070287" y="6254496"/>
             <a:ext cx="1463040" cy="274320"/>
           </a:xfrm>
@@ -15491,45 +15062,6 @@
         </p:nvSpPr>
         <p:spPr>
           <a:xfrm>
-            <a:off x="786384" y="6254496"/>
-            <a:ext cx="8229600" cy="274320"/>
-          </a:xfrm>
-          <a:prstGeom prst="rect">
-            <a:avLst/>
-          </a:prstGeom>
-          <a:noFill/>
-        </p:spPr>
-        <p:txBody>
-          <a:bodyPr wrap="square" lIns="0" rIns="0" tIns="0" bIns="0">
-            <a:spAutoFit/>
-          </a:bodyPr>
-          <a:lstStyle/>
-          <a:p>
-            <a:pPr algn="l">
-              <a:spcBef>
-                <a:spcPts val="0"/>
-              </a:spcBef>
-            </a:pPr>
-            <a:r>
-              <a:rPr sz="900" b="0">
-                <a:solidFill>
-                  <a:srgbClr val="52514E"/>
-                </a:solidFill>
-                <a:latin typeface="Segoe UI"/>
-              </a:rPr>
-              <a:t>D18   ·   16:20   ·   C4.2.3   ·   criteres 16</a:t>
-            </a:r>
-          </a:p>
-        </p:txBody>
-      </p:sp>
-      <p:sp>
-        <p:nvSpPr>
-          <p:cNvPr id="10" name="TextBox 9"/>
-          <p:cNvSpPr txBox="1"/>
-          <p:nvPr/>
-        </p:nvSpPr>
-        <p:spPr>
-          <a:xfrm>
             <a:off x="10070287" y="6254496"/>
             <a:ext cx="1463040" cy="274320"/>
           </a:xfrm>
@@ -16227,45 +15759,6 @@
         </p:nvSpPr>
         <p:spPr>
           <a:xfrm>
-            <a:off x="786384" y="6254496"/>
-            <a:ext cx="8229600" cy="274320"/>
-          </a:xfrm>
-          <a:prstGeom prst="rect">
-            <a:avLst/>
-          </a:prstGeom>
-          <a:noFill/>
-        </p:spPr>
-        <p:txBody>
-          <a:bodyPr wrap="square" lIns="0" rIns="0" tIns="0" bIns="0">
-            <a:spAutoFit/>
-          </a:bodyPr>
-          <a:lstStyle/>
-          <a:p>
-            <a:pPr algn="l">
-              <a:spcBef>
-                <a:spcPts val="0"/>
-              </a:spcBef>
-            </a:pPr>
-            <a:r>
-              <a:rPr sz="900" b="0">
-                <a:solidFill>
-                  <a:srgbClr val="52514E"/>
-                </a:solidFill>
-                <a:latin typeface="Segoe UI"/>
-              </a:rPr>
-              <a:t>D19   ·   17:30   ·   C4.3.1   ·   criteres 17, 18</a:t>
-            </a:r>
-          </a:p>
-        </p:txBody>
-      </p:sp>
-      <p:sp>
-        <p:nvSpPr>
-          <p:cNvPr id="18" name="TextBox 17"/>
-          <p:cNvSpPr txBox="1"/>
-          <p:nvPr/>
-        </p:nvSpPr>
-        <p:spPr>
-          <a:xfrm>
             <a:off x="10070287" y="6254496"/>
             <a:ext cx="1463040" cy="274320"/>
           </a:xfrm>
@@ -16799,45 +16292,6 @@
         </p:nvSpPr>
         <p:spPr>
           <a:xfrm>
-            <a:off x="786384" y="6254496"/>
-            <a:ext cx="8229600" cy="274320"/>
-          </a:xfrm>
-          <a:prstGeom prst="rect">
-            <a:avLst/>
-          </a:prstGeom>
-          <a:noFill/>
-        </p:spPr>
-        <p:txBody>
-          <a:bodyPr wrap="square" lIns="0" rIns="0" tIns="0" bIns="0">
-            <a:spAutoFit/>
-          </a:bodyPr>
-          <a:lstStyle/>
-          <a:p>
-            <a:pPr algn="l">
-              <a:spcBef>
-                <a:spcPts val="0"/>
-              </a:spcBef>
-            </a:pPr>
-            <a:r>
-              <a:rPr sz="900" b="0">
-                <a:solidFill>
-                  <a:srgbClr val="52514E"/>
-                </a:solidFill>
-                <a:latin typeface="Segoe UI"/>
-              </a:rPr>
-              <a:t>D20   ·   18:30   ·   C4.3.1   ·   criteres 19</a:t>
-            </a:r>
-          </a:p>
-        </p:txBody>
-      </p:sp>
-      <p:sp>
-        <p:nvSpPr>
-          <p:cNvPr id="13" name="TextBox 12"/>
-          <p:cNvSpPr txBox="1"/>
-          <p:nvPr/>
-        </p:nvSpPr>
-        <p:spPr>
-          <a:xfrm>
             <a:off x="10070287" y="6254496"/>
             <a:ext cx="1463040" cy="274320"/>
           </a:xfrm>
@@ -17414,45 +16868,6 @@
         </p:nvSpPr>
         <p:spPr>
           <a:xfrm>
-            <a:off x="786384" y="6254496"/>
-            <a:ext cx="8229600" cy="274320"/>
-          </a:xfrm>
-          <a:prstGeom prst="rect">
-            <a:avLst/>
-          </a:prstGeom>
-          <a:noFill/>
-        </p:spPr>
-        <p:txBody>
-          <a:bodyPr wrap="square" lIns="0" rIns="0" tIns="0" bIns="0">
-            <a:spAutoFit/>
-          </a:bodyPr>
-          <a:lstStyle/>
-          <a:p>
-            <a:pPr algn="l">
-              <a:spcBef>
-                <a:spcPts val="0"/>
-              </a:spcBef>
-            </a:pPr>
-            <a:r>
-              <a:rPr sz="900" b="0">
-                <a:solidFill>
-                  <a:srgbClr val="52514E"/>
-                </a:solidFill>
-                <a:latin typeface="Segoe UI"/>
-              </a:rPr>
-              <a:t>D20r   ·   18:30   ·   C4.3.1   ·   criteres 19</a:t>
-            </a:r>
-          </a:p>
-        </p:txBody>
-      </p:sp>
-      <p:sp>
-        <p:nvSpPr>
-          <p:cNvPr id="10" name="TextBox 9"/>
-          <p:cNvSpPr txBox="1"/>
-          <p:nvPr/>
-        </p:nvSpPr>
-        <p:spPr>
-          <a:xfrm>
             <a:off x="10070287" y="6254496"/>
             <a:ext cx="1463040" cy="274320"/>
           </a:xfrm>
@@ -18111,45 +17526,6 @@
         </p:nvSpPr>
         <p:spPr>
           <a:xfrm>
-            <a:off x="786384" y="6254496"/>
-            <a:ext cx="8229600" cy="274320"/>
-          </a:xfrm>
-          <a:prstGeom prst="rect">
-            <a:avLst/>
-          </a:prstGeom>
-          <a:noFill/>
-        </p:spPr>
-        <p:txBody>
-          <a:bodyPr wrap="square" lIns="0" rIns="0" tIns="0" bIns="0">
-            <a:spAutoFit/>
-          </a:bodyPr>
-          <a:lstStyle/>
-          <a:p>
-            <a:pPr algn="l">
-              <a:spcBef>
-                <a:spcPts val="0"/>
-              </a:spcBef>
-            </a:pPr>
-            <a:r>
-              <a:rPr sz="900" b="0">
-                <a:solidFill>
-                  <a:srgbClr val="52514E"/>
-                </a:solidFill>
-                <a:latin typeface="Segoe UI"/>
-              </a:rPr>
-              <a:t>D21   ·   19:30   ·   C4.3.1   ·   criteres 20</a:t>
-            </a:r>
-          </a:p>
-        </p:txBody>
-      </p:sp>
-      <p:sp>
-        <p:nvSpPr>
-          <p:cNvPr id="17" name="TextBox 16"/>
-          <p:cNvSpPr txBox="1"/>
-          <p:nvPr/>
-        </p:nvSpPr>
-        <p:spPr>
-          <a:xfrm>
             <a:off x="10070287" y="6254496"/>
             <a:ext cx="1463040" cy="274320"/>
           </a:xfrm>
@@ -18761,45 +18137,6 @@
         </p:nvSpPr>
         <p:spPr>
           <a:xfrm>
-            <a:off x="786384" y="6254496"/>
-            <a:ext cx="8229600" cy="274320"/>
-          </a:xfrm>
-          <a:prstGeom prst="rect">
-            <a:avLst/>
-          </a:prstGeom>
-          <a:noFill/>
-        </p:spPr>
-        <p:txBody>
-          <a:bodyPr wrap="square" lIns="0" rIns="0" tIns="0" bIns="0">
-            <a:spAutoFit/>
-          </a:bodyPr>
-          <a:lstStyle/>
-          <a:p>
-            <a:pPr algn="l">
-              <a:spcBef>
-                <a:spcPts val="0"/>
-              </a:spcBef>
-            </a:pPr>
-            <a:r>
-              <a:rPr sz="900" b="0">
-                <a:solidFill>
-                  <a:srgbClr val="52514E"/>
-                </a:solidFill>
-                <a:latin typeface="Segoe UI"/>
-              </a:rPr>
-              <a:t>D22   ·   20:30   ·   C4.3.2   ·   criteres 21, 22, 23</a:t>
-            </a:r>
-          </a:p>
-        </p:txBody>
-      </p:sp>
-      <p:sp>
-        <p:nvSpPr>
-          <p:cNvPr id="16" name="TextBox 15"/>
-          <p:cNvSpPr txBox="1"/>
-          <p:nvPr/>
-        </p:nvSpPr>
-        <p:spPr>
-          <a:xfrm>
             <a:off x="10070287" y="6254496"/>
             <a:ext cx="1463040" cy="274320"/>
           </a:xfrm>
@@ -19599,45 +18936,6 @@
         </p:nvSpPr>
         <p:spPr>
           <a:xfrm>
-            <a:off x="786384" y="6254496"/>
-            <a:ext cx="8229600" cy="274320"/>
-          </a:xfrm>
-          <a:prstGeom prst="rect">
-            <a:avLst/>
-          </a:prstGeom>
-          <a:noFill/>
-        </p:spPr>
-        <p:txBody>
-          <a:bodyPr wrap="square" lIns="0" rIns="0" tIns="0" bIns="0">
-            <a:spAutoFit/>
-          </a:bodyPr>
-          <a:lstStyle/>
-          <a:p>
-            <a:pPr algn="l">
-              <a:spcBef>
-                <a:spcPts val="0"/>
-              </a:spcBef>
-            </a:pPr>
-            <a:r>
-              <a:rPr sz="900" b="0">
-                <a:solidFill>
-                  <a:srgbClr val="52514E"/>
-                </a:solidFill>
-                <a:latin typeface="Segoe UI"/>
-              </a:rPr>
-              <a:t>D23   ·   21:30   ·   C4.3.2   ·   criteres 24</a:t>
-            </a:r>
-          </a:p>
-        </p:txBody>
-      </p:sp>
-      <p:sp>
-        <p:nvSpPr>
-          <p:cNvPr id="20" name="TextBox 19"/>
-          <p:cNvSpPr txBox="1"/>
-          <p:nvPr/>
-        </p:nvSpPr>
-        <p:spPr>
-          <a:xfrm>
             <a:off x="10070287" y="6254496"/>
             <a:ext cx="1463040" cy="274320"/>
           </a:xfrm>
@@ -20249,45 +19547,6 @@
         </p:nvSpPr>
         <p:spPr>
           <a:xfrm>
-            <a:off x="786384" y="6254496"/>
-            <a:ext cx="8229600" cy="274320"/>
-          </a:xfrm>
-          <a:prstGeom prst="rect">
-            <a:avLst/>
-          </a:prstGeom>
-          <a:noFill/>
-        </p:spPr>
-        <p:txBody>
-          <a:bodyPr wrap="square" lIns="0" rIns="0" tIns="0" bIns="0">
-            <a:spAutoFit/>
-          </a:bodyPr>
-          <a:lstStyle/>
-          <a:p>
-            <a:pPr algn="l">
-              <a:spcBef>
-                <a:spcPts val="0"/>
-              </a:spcBef>
-            </a:pPr>
-            <a:r>
-              <a:rPr sz="900" b="0">
-                <a:solidFill>
-                  <a:srgbClr val="52514E"/>
-                </a:solidFill>
-                <a:latin typeface="Segoe UI"/>
-              </a:rPr>
-              <a:t>D24   ·   22:30   ·   C4.3.3   ·   criteres 25</a:t>
-            </a:r>
-          </a:p>
-        </p:txBody>
-      </p:sp>
-      <p:sp>
-        <p:nvSpPr>
-          <p:cNvPr id="16" name="TextBox 15"/>
-          <p:cNvSpPr txBox="1"/>
-          <p:nvPr/>
-        </p:nvSpPr>
-        <p:spPr>
-          <a:xfrm>
             <a:off x="10070287" y="6254496"/>
             <a:ext cx="1463040" cy="274320"/>
           </a:xfrm>
@@ -20618,45 +19877,6 @@
         </p:nvSpPr>
         <p:spPr>
           <a:xfrm>
-            <a:off x="786384" y="6254496"/>
-            <a:ext cx="8229600" cy="274320"/>
-          </a:xfrm>
-          <a:prstGeom prst="rect">
-            <a:avLst/>
-          </a:prstGeom>
-          <a:noFill/>
-        </p:spPr>
-        <p:txBody>
-          <a:bodyPr wrap="square" lIns="0" rIns="0" tIns="0" bIns="0">
-            <a:spAutoFit/>
-          </a:bodyPr>
-          <a:lstStyle/>
-          <a:p>
-            <a:pPr algn="l">
-              <a:spcBef>
-                <a:spcPts val="0"/>
-              </a:spcBef>
-            </a:pPr>
-            <a:r>
-              <a:rPr sz="900" b="0">
-                <a:solidFill>
-                  <a:srgbClr val="52514E"/>
-                </a:solidFill>
-                <a:latin typeface="Segoe UI"/>
-              </a:rPr>
-              <a:t>D25   ·   23:30   ·   C4.4.1   ·   criteres 26, 27</a:t>
-            </a:r>
-          </a:p>
-        </p:txBody>
-      </p:sp>
-      <p:sp>
-        <p:nvSpPr>
-          <p:cNvPr id="10" name="TextBox 9"/>
-          <p:cNvSpPr txBox="1"/>
-          <p:nvPr/>
-        </p:nvSpPr>
-        <p:spPr>
-          <a:xfrm>
             <a:off x="10070287" y="6254496"/>
             <a:ext cx="1463040" cy="274320"/>
           </a:xfrm>
@@ -21229,45 +20449,6 @@
         </p:nvSpPr>
         <p:spPr>
           <a:xfrm>
-            <a:off x="786384" y="6254496"/>
-            <a:ext cx="8229600" cy="274320"/>
-          </a:xfrm>
-          <a:prstGeom prst="rect">
-            <a:avLst/>
-          </a:prstGeom>
-          <a:noFill/>
-        </p:spPr>
-        <p:txBody>
-          <a:bodyPr wrap="square" lIns="0" rIns="0" tIns="0" bIns="0">
-            <a:spAutoFit/>
-          </a:bodyPr>
-          <a:lstStyle/>
-          <a:p>
-            <a:pPr algn="l">
-              <a:spcBef>
-                <a:spcPts val="0"/>
-              </a:spcBef>
-            </a:pPr>
-            <a:r>
-              <a:rPr sz="900" b="0">
-                <a:solidFill>
-                  <a:srgbClr val="52514E"/>
-                </a:solidFill>
-                <a:latin typeface="Segoe UI"/>
-              </a:rPr>
-              <a:t>D26   ·   24:15   ·   C4.4.1   ·   criteres 27</a:t>
-            </a:r>
-          </a:p>
-        </p:txBody>
-      </p:sp>
-      <p:sp>
-        <p:nvSpPr>
-          <p:cNvPr id="15" name="TextBox 14"/>
-          <p:cNvSpPr txBox="1"/>
-          <p:nvPr/>
-        </p:nvSpPr>
-        <p:spPr>
-          <a:xfrm>
             <a:off x="10070287" y="6254496"/>
             <a:ext cx="1463040" cy="274320"/>
           </a:xfrm>
@@ -21965,45 +21146,6 @@
         </p:nvSpPr>
         <p:spPr>
           <a:xfrm>
-            <a:off x="786384" y="6254496"/>
-            <a:ext cx="8229600" cy="274320"/>
-          </a:xfrm>
-          <a:prstGeom prst="rect">
-            <a:avLst/>
-          </a:prstGeom>
-          <a:noFill/>
-        </p:spPr>
-        <p:txBody>
-          <a:bodyPr wrap="square" lIns="0" rIns="0" tIns="0" bIns="0">
-            <a:spAutoFit/>
-          </a:bodyPr>
-          <a:lstStyle/>
-          <a:p>
-            <a:pPr algn="l">
-              <a:spcBef>
-                <a:spcPts val="0"/>
-              </a:spcBef>
-            </a:pPr>
-            <a:r>
-              <a:rPr sz="900" b="0">
-                <a:solidFill>
-                  <a:srgbClr val="52514E"/>
-                </a:solidFill>
-                <a:latin typeface="Segoe UI"/>
-              </a:rPr>
-              <a:t>D03   ·   01:00   ·   C4.1.1   ·   criteres 1, 2</a:t>
-            </a:r>
-          </a:p>
-        </p:txBody>
-      </p:sp>
-      <p:sp>
-        <p:nvSpPr>
-          <p:cNvPr id="18" name="TextBox 17"/>
-          <p:cNvSpPr txBox="1"/>
-          <p:nvPr/>
-        </p:nvSpPr>
-        <p:spPr>
-          <a:xfrm>
             <a:off x="10070287" y="6254496"/>
             <a:ext cx="1463040" cy="274320"/>
           </a:xfrm>
@@ -22603,45 +21745,6 @@
         </p:nvSpPr>
         <p:spPr>
           <a:xfrm>
-            <a:off x="786384" y="6254496"/>
-            <a:ext cx="8229600" cy="274320"/>
-          </a:xfrm>
-          <a:prstGeom prst="rect">
-            <a:avLst/>
-          </a:prstGeom>
-          <a:noFill/>
-        </p:spPr>
-        <p:txBody>
-          <a:bodyPr wrap="square" lIns="0" rIns="0" tIns="0" bIns="0">
-            <a:spAutoFit/>
-          </a:bodyPr>
-          <a:lstStyle/>
-          <a:p>
-            <a:pPr algn="l">
-              <a:spcBef>
-                <a:spcPts val="0"/>
-              </a:spcBef>
-            </a:pPr>
-            <a:r>
-              <a:rPr sz="900" b="0">
-                <a:solidFill>
-                  <a:srgbClr val="52514E"/>
-                </a:solidFill>
-                <a:latin typeface="Segoe UI"/>
-              </a:rPr>
-              <a:t>D27   ·   25:00   ·   C4.4.2   ·   criteres 28</a:t>
-            </a:r>
-          </a:p>
-        </p:txBody>
-      </p:sp>
-      <p:sp>
-        <p:nvSpPr>
-          <p:cNvPr id="11" name="TextBox 10"/>
-          <p:cNvSpPr txBox="1"/>
-          <p:nvPr/>
-        </p:nvSpPr>
-        <p:spPr>
-          <a:xfrm>
             <a:off x="10070287" y="6254496"/>
             <a:ext cx="1463040" cy="274320"/>
           </a:xfrm>
@@ -22933,45 +22036,6 @@
         </p:nvSpPr>
         <p:spPr>
           <a:xfrm>
-            <a:off x="786384" y="6254496"/>
-            <a:ext cx="8229600" cy="274320"/>
-          </a:xfrm>
-          <a:prstGeom prst="rect">
-            <a:avLst/>
-          </a:prstGeom>
-          <a:noFill/>
-        </p:spPr>
-        <p:txBody>
-          <a:bodyPr wrap="square" lIns="0" rIns="0" tIns="0" bIns="0">
-            <a:spAutoFit/>
-          </a:bodyPr>
-          <a:lstStyle/>
-          <a:p>
-            <a:pPr algn="l">
-              <a:spcBef>
-                <a:spcPts val="0"/>
-              </a:spcBef>
-            </a:pPr>
-            <a:r>
-              <a:rPr sz="900" b="0">
-                <a:solidFill>
-                  <a:srgbClr val="52514E"/>
-                </a:solidFill>
-                <a:latin typeface="Segoe UI"/>
-              </a:rPr>
-              <a:t>D28   ·   26:00   ·   C4.4.2   ·   criteres 29, 30, 31</a:t>
-            </a:r>
-          </a:p>
-        </p:txBody>
-      </p:sp>
-      <p:sp>
-        <p:nvSpPr>
-          <p:cNvPr id="9" name="TextBox 8"/>
-          <p:cNvSpPr txBox="1"/>
-          <p:nvPr/>
-        </p:nvSpPr>
-        <p:spPr>
-          <a:xfrm>
             <a:off x="10070287" y="6254496"/>
             <a:ext cx="1463040" cy="274320"/>
           </a:xfrm>
@@ -23638,45 +22702,6 @@
         </p:nvSpPr>
         <p:spPr>
           <a:xfrm>
-            <a:off x="786384" y="6254496"/>
-            <a:ext cx="8229600" cy="274320"/>
-          </a:xfrm>
-          <a:prstGeom prst="rect">
-            <a:avLst/>
-          </a:prstGeom>
-          <a:noFill/>
-        </p:spPr>
-        <p:txBody>
-          <a:bodyPr wrap="square" lIns="0" rIns="0" tIns="0" bIns="0">
-            <a:spAutoFit/>
-          </a:bodyPr>
-          <a:lstStyle/>
-          <a:p>
-            <a:pPr algn="l">
-              <a:spcBef>
-                <a:spcPts val="0"/>
-              </a:spcBef>
-            </a:pPr>
-            <a:r>
-              <a:rPr sz="900" b="0">
-                <a:solidFill>
-                  <a:srgbClr val="52514E"/>
-                </a:solidFill>
-                <a:latin typeface="Segoe UI"/>
-              </a:rPr>
-              <a:t>D29   ·   27:00</a:t>
-            </a:r>
-          </a:p>
-        </p:txBody>
-      </p:sp>
-      <p:sp>
-        <p:nvSpPr>
-          <p:cNvPr id="17" name="TextBox 16"/>
-          <p:cNvSpPr txBox="1"/>
-          <p:nvPr/>
-        </p:nvSpPr>
-        <p:spPr>
-          <a:xfrm>
             <a:off x="10070287" y="6254496"/>
             <a:ext cx="1463040" cy="274320"/>
           </a:xfrm>
@@ -25019,45 +24044,6 @@
         </p:nvSpPr>
         <p:spPr>
           <a:xfrm>
-            <a:off x="786384" y="6254496"/>
-            <a:ext cx="8229600" cy="274320"/>
-          </a:xfrm>
-          <a:prstGeom prst="rect">
-            <a:avLst/>
-          </a:prstGeom>
-          <a:noFill/>
-        </p:spPr>
-        <p:txBody>
-          <a:bodyPr wrap="square" lIns="0" rIns="0" tIns="0" bIns="0">
-            <a:spAutoFit/>
-          </a:bodyPr>
-          <a:lstStyle/>
-          <a:p>
-            <a:pPr algn="l">
-              <a:spcBef>
-                <a:spcPts val="0"/>
-              </a:spcBef>
-            </a:pPr>
-            <a:r>
-              <a:rPr sz="900" b="0">
-                <a:solidFill>
-                  <a:srgbClr val="52514E"/>
-                </a:solidFill>
-                <a:latin typeface="Segoe UI"/>
-              </a:rPr>
-              <a:t>D04   ·   02:00   ·   C4.1.1   ·   criteres 5, 2</a:t>
-            </a:r>
-          </a:p>
-        </p:txBody>
-      </p:sp>
-      <p:sp>
-        <p:nvSpPr>
-          <p:cNvPr id="27" name="TextBox 26"/>
-          <p:cNvSpPr txBox="1"/>
-          <p:nvPr/>
-        </p:nvSpPr>
-        <p:spPr>
-          <a:xfrm>
             <a:off x="10070287" y="6254496"/>
             <a:ext cx="1463040" cy="274320"/>
           </a:xfrm>
@@ -25716,45 +24702,6 @@
         </p:nvSpPr>
         <p:spPr>
           <a:xfrm>
-            <a:off x="786384" y="6254496"/>
-            <a:ext cx="8229600" cy="274320"/>
-          </a:xfrm>
-          <a:prstGeom prst="rect">
-            <a:avLst/>
-          </a:prstGeom>
-          <a:noFill/>
-        </p:spPr>
-        <p:txBody>
-          <a:bodyPr wrap="square" lIns="0" rIns="0" tIns="0" bIns="0">
-            <a:spAutoFit/>
-          </a:bodyPr>
-          <a:lstStyle/>
-          <a:p>
-            <a:pPr algn="l">
-              <a:spcBef>
-                <a:spcPts val="0"/>
-              </a:spcBef>
-            </a:pPr>
-            <a:r>
-              <a:rPr sz="900" b="0">
-                <a:solidFill>
-                  <a:srgbClr val="52514E"/>
-                </a:solidFill>
-                <a:latin typeface="Segoe UI"/>
-              </a:rPr>
-              <a:t>D05   ·   02:50   ·   C4.1.1   ·   criteres 3, 4</a:t>
-            </a:r>
-          </a:p>
-        </p:txBody>
-      </p:sp>
-      <p:sp>
-        <p:nvSpPr>
-          <p:cNvPr id="17" name="TextBox 16"/>
-          <p:cNvSpPr txBox="1"/>
-          <p:nvPr/>
-        </p:nvSpPr>
-        <p:spPr>
-          <a:xfrm>
             <a:off x="10070287" y="6254496"/>
             <a:ext cx="1463040" cy="274320"/>
           </a:xfrm>
@@ -26085,45 +25032,6 @@
         </p:nvSpPr>
         <p:spPr>
           <a:xfrm>
-            <a:off x="786384" y="6254496"/>
-            <a:ext cx="8229600" cy="274320"/>
-          </a:xfrm>
-          <a:prstGeom prst="rect">
-            <a:avLst/>
-          </a:prstGeom>
-          <a:noFill/>
-        </p:spPr>
-        <p:txBody>
-          <a:bodyPr wrap="square" lIns="0" rIns="0" tIns="0" bIns="0">
-            <a:spAutoFit/>
-          </a:bodyPr>
-          <a:lstStyle/>
-          <a:p>
-            <a:pPr algn="l">
-              <a:spcBef>
-                <a:spcPts val="0"/>
-              </a:spcBef>
-            </a:pPr>
-            <a:r>
-              <a:rPr sz="900" b="0">
-                <a:solidFill>
-                  <a:srgbClr val="52514E"/>
-                </a:solidFill>
-                <a:latin typeface="Segoe UI"/>
-              </a:rPr>
-              <a:t>D06   ·   03:30   ·   C4.1.2   ·   criteres 6, 7</a:t>
-            </a:r>
-          </a:p>
-        </p:txBody>
-      </p:sp>
-      <p:sp>
-        <p:nvSpPr>
-          <p:cNvPr id="10" name="TextBox 9"/>
-          <p:cNvSpPr txBox="1"/>
-          <p:nvPr/>
-        </p:nvSpPr>
-        <p:spPr>
-          <a:xfrm>
             <a:off x="10070287" y="6254496"/>
             <a:ext cx="1463040" cy="274320"/>
           </a:xfrm>
@@ -26782,45 +25690,6 @@
         </p:nvSpPr>
         <p:spPr>
           <a:xfrm>
-            <a:off x="786384" y="6254496"/>
-            <a:ext cx="8229600" cy="274320"/>
-          </a:xfrm>
-          <a:prstGeom prst="rect">
-            <a:avLst/>
-          </a:prstGeom>
-          <a:noFill/>
-        </p:spPr>
-        <p:txBody>
-          <a:bodyPr wrap="square" lIns="0" rIns="0" tIns="0" bIns="0">
-            <a:spAutoFit/>
-          </a:bodyPr>
-          <a:lstStyle/>
-          <a:p>
-            <a:pPr algn="l">
-              <a:spcBef>
-                <a:spcPts val="0"/>
-              </a:spcBef>
-            </a:pPr>
-            <a:r>
-              <a:rPr sz="900" b="0">
-                <a:solidFill>
-                  <a:srgbClr val="52514E"/>
-                </a:solidFill>
-                <a:latin typeface="Segoe UI"/>
-              </a:rPr>
-              <a:t>D07   ·   04:40   ·   C4.1.2   ·   criteres 8</a:t>
-            </a:r>
-          </a:p>
-        </p:txBody>
-      </p:sp>
-      <p:sp>
-        <p:nvSpPr>
-          <p:cNvPr id="17" name="TextBox 16"/>
-          <p:cNvSpPr txBox="1"/>
-          <p:nvPr/>
-        </p:nvSpPr>
-        <p:spPr>
-          <a:xfrm>
             <a:off x="10070287" y="6254496"/>
             <a:ext cx="1463040" cy="274320"/>
           </a:xfrm>
@@ -27112,45 +25981,6 @@
         </p:nvSpPr>
         <p:spPr>
           <a:xfrm>
-            <a:off x="786384" y="6254496"/>
-            <a:ext cx="8229600" cy="274320"/>
-          </a:xfrm>
-          <a:prstGeom prst="rect">
-            <a:avLst/>
-          </a:prstGeom>
-          <a:noFill/>
-        </p:spPr>
-        <p:txBody>
-          <a:bodyPr wrap="square" lIns="0" rIns="0" tIns="0" bIns="0">
-            <a:spAutoFit/>
-          </a:bodyPr>
-          <a:lstStyle/>
-          <a:p>
-            <a:pPr algn="l">
-              <a:spcBef>
-                <a:spcPts val="0"/>
-              </a:spcBef>
-            </a:pPr>
-            <a:r>
-              <a:rPr sz="900" b="0">
-                <a:solidFill>
-                  <a:srgbClr val="52514E"/>
-                </a:solidFill>
-                <a:latin typeface="Segoe UI"/>
-              </a:rPr>
-              <a:t>D08   ·   05:30   ·   C4.1.2   ·   criteres 9</a:t>
-            </a:r>
-          </a:p>
-        </p:txBody>
-      </p:sp>
-      <p:sp>
-        <p:nvSpPr>
-          <p:cNvPr id="9" name="TextBox 8"/>
-          <p:cNvSpPr txBox="1"/>
-          <p:nvPr/>
-        </p:nvSpPr>
-        <p:spPr>
-          <a:xfrm>
             <a:off x="10070287" y="6254496"/>
             <a:ext cx="1463040" cy="274320"/>
           </a:xfrm>
@@ -27476,45 +26306,6 @@
       <p:sp>
         <p:nvSpPr>
           <p:cNvPr id="9" name="TextBox 8"/>
-          <p:cNvSpPr txBox="1"/>
-          <p:nvPr/>
-        </p:nvSpPr>
-        <p:spPr>
-          <a:xfrm>
-            <a:off x="786384" y="6254496"/>
-            <a:ext cx="8229600" cy="274320"/>
-          </a:xfrm>
-          <a:prstGeom prst="rect">
-            <a:avLst/>
-          </a:prstGeom>
-          <a:noFill/>
-        </p:spPr>
-        <p:txBody>
-          <a:bodyPr wrap="square" lIns="0" rIns="0" tIns="0" bIns="0">
-            <a:spAutoFit/>
-          </a:bodyPr>
-          <a:lstStyle/>
-          <a:p>
-            <a:pPr algn="l">
-              <a:spcBef>
-                <a:spcPts val="0"/>
-              </a:spcBef>
-            </a:pPr>
-            <a:r>
-              <a:rPr sz="900" b="0">
-                <a:solidFill>
-                  <a:srgbClr val="52514E"/>
-                </a:solidFill>
-                <a:latin typeface="Segoe UI"/>
-              </a:rPr>
-              <a:t>D09   ·   06:30   ·   C4.2.1   ·   criteres 10, 12</a:t>
-            </a:r>
-          </a:p>
-        </p:txBody>
-      </p:sp>
-      <p:sp>
-        <p:nvSpPr>
-          <p:cNvPr id="10" name="TextBox 9"/>
           <p:cNvSpPr txBox="1"/>
           <p:nvPr/>
         </p:nvSpPr>

</xml_diff>